<commit_message>
Tidy the deck after a design pass
Hand-break the headlines. Six of them were orphaning their last word or
splitting a number range, which is the clearest sign a program laid the slide
out rather than a person.

Re-shoot the incident record at 3x. On the proof slide it was about 132 DPI,
which is unreadable in an email preview. It is now about 395.

Pin every footnote to the same height, and add the two that were missing, so
the bottom of the page closes the same way on every slide.

Trim the flat tail off the early warning chart and drop the caption on the
venture chart that repeated its own headline.

Correct pitch/NOTES.md: it claimed numbers in a headline and in a chart match.
They do not. Georgia sets old-style figures. Keeping it, saying so.
</commit_message>
<xml_diff>
--- a/pitch/Kintrace-deck.pptx
+++ b/pitch/Kintrace-deck.pptx
@@ -5352,7 +5352,23 @@
                 </a:solidFill>
                 <a:latin typeface="Georgia"/>
               </a:rPr>
-              <a:t>$200 a robot a month, against a technician visit that costs $1,500 to $3,000.</a:t>
+              <a:t>$200 a robot a month, against a technician visit</a:t>
+            </a:r>
+          </a:p>
+          <a:p>
+            <a:pPr algn="l">
+              <a:lnSpc>
+                <a:spcPct val="116000"/>
+              </a:lnSpc>
+            </a:pPr>
+            <a:r>
+              <a:rPr sz="2900" b="0">
+                <a:solidFill>
+                  <a:srgbClr val="0C0C0E"/>
+                </a:solidFill>
+                <a:latin typeface="Georgia"/>
+              </a:rPr>
+              <a:t>that costs $1,500 to $3,000.</a:t>
             </a:r>
           </a:p>
         </p:txBody>
@@ -5404,7 +5420,7 @@
         </p:nvSpPr>
         <p:spPr>
           <a:xfrm>
-            <a:off x="777240" y="2139696"/>
+            <a:off x="777240" y="2103120"/>
             <a:ext cx="4114800" cy="347472"/>
           </a:xfrm>
           <a:prstGeom prst="rect">
@@ -5443,7 +5459,7 @@
         </p:nvSpPr>
         <p:spPr>
           <a:xfrm>
-            <a:off x="777240" y="2487168"/>
+            <a:off x="777240" y="2450592"/>
             <a:ext cx="3703320" cy="548640"/>
           </a:xfrm>
           <a:prstGeom prst="rect">
@@ -5482,7 +5498,7 @@
         </p:nvSpPr>
         <p:spPr>
           <a:xfrm>
-            <a:off x="777240" y="3127248"/>
+            <a:off x="777240" y="2999232"/>
             <a:ext cx="4114800" cy="347472"/>
           </a:xfrm>
           <a:prstGeom prst="rect">
@@ -5521,7 +5537,7 @@
         </p:nvSpPr>
         <p:spPr>
           <a:xfrm>
-            <a:off x="777240" y="3474720"/>
+            <a:off x="777240" y="3346704"/>
             <a:ext cx="3703320" cy="548640"/>
           </a:xfrm>
           <a:prstGeom prst="rect">
@@ -5560,7 +5576,7 @@
         </p:nvSpPr>
         <p:spPr>
           <a:xfrm>
-            <a:off x="777240" y="4114800"/>
+            <a:off x="777240" y="3895344"/>
             <a:ext cx="4114800" cy="347472"/>
           </a:xfrm>
           <a:prstGeom prst="rect">
@@ -5599,7 +5615,7 @@
         </p:nvSpPr>
         <p:spPr>
           <a:xfrm>
-            <a:off x="777240" y="4462272"/>
+            <a:off x="777240" y="4242816"/>
             <a:ext cx="3703320" cy="548640"/>
           </a:xfrm>
           <a:prstGeom prst="rect">
@@ -5638,7 +5654,7 @@
         </p:nvSpPr>
         <p:spPr>
           <a:xfrm>
-            <a:off x="777240" y="5212080"/>
+            <a:off x="777240" y="4901184"/>
             <a:ext cx="4160520" cy="365760"/>
           </a:xfrm>
           <a:prstGeom prst="rect">
@@ -5677,8 +5693,8 @@
         </p:nvSpPr>
         <p:spPr>
           <a:xfrm>
-            <a:off x="777240" y="5614416"/>
-            <a:ext cx="3703320" cy="1188720"/>
+            <a:off x="777240" y="5285232"/>
+            <a:ext cx="3703320" cy="868680"/>
           </a:xfrm>
           <a:prstGeom prst="rect">
             <a:avLst/>
@@ -6304,6 +6320,45 @@
                 <a:latin typeface="Arial"/>
               </a:rPr>
               <a:t>Software only</a:t>
+            </a:r>
+          </a:p>
+        </p:txBody>
+      </p:sp>
+      <p:sp>
+        <p:nvSpPr>
+          <p:cNvPr id="27" name="TextBox 26"/>
+          <p:cNvSpPr txBox="1"/>
+          <p:nvPr/>
+        </p:nvSpPr>
+        <p:spPr>
+          <a:xfrm>
+            <a:off x="777240" y="6327648"/>
+            <a:ext cx="10637215" cy="365760"/>
+          </a:xfrm>
+          <a:prstGeom prst="rect">
+            <a:avLst/>
+          </a:prstGeom>
+          <a:noFill/>
+        </p:spPr>
+        <p:txBody>
+          <a:bodyPr wrap="square" lIns="0" rIns="0" tIns="0" bIns="0">
+            <a:spAutoFit/>
+          </a:bodyPr>
+          <a:lstStyle/>
+          <a:p>
+            <a:pPr algn="l">
+              <a:lnSpc>
+                <a:spcPct val="120000"/>
+              </a:lnSpc>
+            </a:pPr>
+            <a:r>
+              <a:rPr sz="950" b="0">
+                <a:solidFill>
+                  <a:srgbClr val="76777D"/>
+                </a:solidFill>
+                <a:latin typeface="Arial"/>
+              </a:rPr>
+              <a:t>The $1,500 to $3,000 technician visit is our own estimate from conversations, not a published figure. Our pricing is intended, not yet tested on a buyer.</a:t>
             </a:r>
           </a:p>
         </p:txBody>
@@ -6360,7 +6415,23 @@
                 </a:solidFill>
                 <a:latin typeface="Georgia"/>
               </a:rPr>
-              <a:t>Raising [$150K] to put Kintrace on real arms and into three paid pilots.</a:t>
+              <a:t>Raising [$150K] to put Kintrace on real arms</a:t>
+            </a:r>
+          </a:p>
+          <a:p>
+            <a:pPr algn="l">
+              <a:lnSpc>
+                <a:spcPct val="116000"/>
+              </a:lnSpc>
+            </a:pPr>
+            <a:r>
+              <a:rPr sz="2900" b="0">
+                <a:solidFill>
+                  <a:srgbClr val="0C0C0E"/>
+                </a:solidFill>
+                <a:latin typeface="Georgia"/>
+              </a:rPr>
+              <a:t>and into three paid pilots.</a:t>
             </a:r>
           </a:p>
         </p:txBody>
@@ -8227,7 +8298,7 @@
         </p:nvSpPr>
         <p:spPr>
           <a:xfrm>
-            <a:off x="777240" y="6053328"/>
+            <a:off x="777240" y="6327648"/>
             <a:ext cx="10637215" cy="365760"/>
           </a:xfrm>
           <a:prstGeom prst="rect">
@@ -8310,7 +8381,23 @@
                 </a:solidFill>
                 <a:latin typeface="Georgia"/>
               </a:rPr>
-              <a:t>You pay for it twice: in ruined training data, and in stopped lines.</a:t>
+              <a:t>You pay for it twice: in ruined training data,</a:t>
+            </a:r>
+          </a:p>
+          <a:p>
+            <a:pPr algn="l">
+              <a:lnSpc>
+                <a:spcPct val="116000"/>
+              </a:lnSpc>
+            </a:pPr>
+            <a:r>
+              <a:rPr sz="2900" b="0">
+                <a:solidFill>
+                  <a:srgbClr val="0C0C0E"/>
+                </a:solidFill>
+                <a:latin typeface="Georgia"/>
+              </a:rPr>
+              <a:t>and in stopped lines.</a:t>
             </a:r>
           </a:p>
         </p:txBody>
@@ -8667,7 +8754,23 @@
                 </a:solidFill>
                 <a:latin typeface="Georgia"/>
               </a:rPr>
-              <a:t>Everything on the market tells you something is wrong, not what moved.</a:t>
+              <a:t>Everything on the market tells you something is wrong,</a:t>
+            </a:r>
+          </a:p>
+          <a:p>
+            <a:pPr algn="l">
+              <a:lnSpc>
+                <a:spcPct val="116000"/>
+              </a:lnSpc>
+            </a:pPr>
+            <a:r>
+              <a:rPr sz="2900" b="0">
+                <a:solidFill>
+                  <a:srgbClr val="0C0C0E"/>
+                </a:solidFill>
+                <a:latin typeface="Georgia"/>
+              </a:rPr>
+              <a:t>not what moved.</a:t>
             </a:r>
           </a:p>
         </p:txBody>
@@ -9234,6 +9337,45 @@
                 <a:latin typeface="Arial"/>
               </a:rPr>
               <a:t>We have not found anyone doing all of it from software alone: when it changed, what moved, by how much, and the fix written back.</a:t>
+            </a:r>
+          </a:p>
+        </p:txBody>
+      </p:sp>
+      <p:sp>
+        <p:nvSpPr>
+          <p:cNvPr id="17" name="TextBox 16"/>
+          <p:cNvSpPr txBox="1"/>
+          <p:nvPr/>
+        </p:nvSpPr>
+        <p:spPr>
+          <a:xfrm>
+            <a:off x="777240" y="6327648"/>
+            <a:ext cx="10637215" cy="365760"/>
+          </a:xfrm>
+          <a:prstGeom prst="rect">
+            <a:avLst/>
+          </a:prstGeom>
+          <a:noFill/>
+        </p:spPr>
+        <p:txBody>
+          <a:bodyPr wrap="square" lIns="0" rIns="0" tIns="0" bIns="0">
+            <a:spAutoFit/>
+          </a:bodyPr>
+          <a:lstStyle/>
+          <a:p>
+            <a:pPr algn="l">
+              <a:lnSpc>
+                <a:spcPct val="120000"/>
+              </a:lnSpc>
+            </a:pPr>
+            <a:r>
+              <a:rPr sz="950" b="0">
+                <a:solidFill>
+                  <a:srgbClr val="76777D"/>
+                </a:solidFill>
+                <a:latin typeface="Arial"/>
+              </a:rPr>
+              <a:t>What each of these does is taken from their own sites and materials. Listed in pitch/SOURCES.md.</a:t>
             </a:r>
           </a:p>
         </p:txBody>
@@ -9290,7 +9432,23 @@
                 </a:solidFill>
                 <a:latin typeface="Georgia"/>
               </a:rPr>
-              <a:t>Kintrace reads the robot's own logs, then says what moved and writes the fix.</a:t>
+              <a:t>Kintrace reads the robot's own logs, then says</a:t>
+            </a:r>
+          </a:p>
+          <a:p>
+            <a:pPr algn="l">
+              <a:lnSpc>
+                <a:spcPct val="116000"/>
+              </a:lnSpc>
+            </a:pPr>
+            <a:r>
+              <a:rPr sz="2900" b="0">
+                <a:solidFill>
+                  <a:srgbClr val="0C0C0E"/>
+                </a:solidFill>
+                <a:latin typeface="Georgia"/>
+              </a:rPr>
+              <a:t>what moved and writes the fix.</a:t>
             </a:r>
           </a:p>
         </p:txBody>
@@ -9693,7 +9851,7 @@
         </p:nvSpPr>
         <p:spPr>
           <a:xfrm>
-            <a:off x="777240" y="6016752"/>
+            <a:off x="777240" y="6327648"/>
             <a:ext cx="7863840" cy="365760"/>
           </a:xfrm>
           <a:prstGeom prst="rect">
@@ -9776,7 +9934,23 @@
                 </a:solidFill>
                 <a:latin typeface="Georgia"/>
               </a:rPr>
-              <a:t>In our simulator, Kintrace named the right cause every time. The dashboard baseline we wrote got 69%.</a:t>
+              <a:t>In our simulator, Kintrace named the right cause</a:t>
+            </a:r>
+          </a:p>
+          <a:p>
+            <a:pPr algn="l">
+              <a:lnSpc>
+                <a:spcPct val="116000"/>
+              </a:lnSpc>
+            </a:pPr>
+            <a:r>
+              <a:rPr sz="2900" b="0">
+                <a:solidFill>
+                  <a:srgbClr val="0C0C0E"/>
+                </a:solidFill>
+                <a:latin typeface="Georgia"/>
+              </a:rPr>
+              <a:t>every time. The dashboard baseline we wrote got 69%.</a:t>
             </a:r>
           </a:p>
         </p:txBody>
@@ -9896,7 +10070,23 @@
                 </a:solidFill>
                 <a:latin typeface="Georgia"/>
               </a:rPr>
-              <a:t>It also catches slow drift, about 55 seconds before the first grab misses.</a:t>
+              <a:t>It also catches slow drift, about 55 seconds</a:t>
+            </a:r>
+          </a:p>
+          <a:p>
+            <a:pPr algn="l">
+              <a:lnSpc>
+                <a:spcPct val="116000"/>
+              </a:lnSpc>
+            </a:pPr>
+            <a:r>
+              <a:rPr sz="2900" b="0">
+                <a:solidFill>
+                  <a:srgbClr val="0C0C0E"/>
+                </a:solidFill>
+                <a:latin typeface="Georgia"/>
+              </a:rPr>
+              <a:t>before the first grab misses.</a:t>
             </a:r>
           </a:p>
         </p:txBody>
@@ -10016,7 +10206,23 @@
                 </a:solidFill>
                 <a:latin typeface="Georgia"/>
               </a:rPr>
-              <a:t>There have never been more robots, and the money behind them doubled in three years.</a:t>
+              <a:t>There have never been more robots, and the money</a:t>
+            </a:r>
+          </a:p>
+          <a:p>
+            <a:pPr algn="l">
+              <a:lnSpc>
+                <a:spcPct val="116000"/>
+              </a:lnSpc>
+            </a:pPr>
+            <a:r>
+              <a:rPr sz="2900" b="0">
+                <a:solidFill>
+                  <a:srgbClr val="0C0C0E"/>
+                </a:solidFill>
+                <a:latin typeface="Georgia"/>
+              </a:rPr>
+              <a:t>behind them doubled in three years.</a:t>
             </a:r>
           </a:p>
         </p:txBody>
@@ -10380,7 +10586,23 @@
                 </a:solidFill>
                 <a:latin typeface="Georgia"/>
               </a:rPr>
-              <a:t>At $200 a robot a month, the part we can realistically sell to is $1.2B a year.</a:t>
+              <a:t>At $200 a robot a month, the part we can</a:t>
+            </a:r>
+          </a:p>
+          <a:p>
+            <a:pPr algn="l">
+              <a:lnSpc>
+                <a:spcPct val="116000"/>
+              </a:lnSpc>
+            </a:pPr>
+            <a:r>
+              <a:rPr sz="2900" b="0">
+                <a:solidFill>
+                  <a:srgbClr val="0C0C0E"/>
+                </a:solidFill>
+                <a:latin typeface="Georgia"/>
+              </a:rPr>
+              <a:t>realistically sell to is $1.2B a year.</a:t>
             </a:r>
           </a:p>
         </p:txBody>

</xml_diff>